<commit_message>
Remove AXI/PL slot payload source bullet from Slave multi-slot simulation slide
Co-Authored-By: Claude Sonnet 4.6 <noreply@anthropic.com>
Claude-Session: https://claude.ai/code/session_01HsnhTJYvcfwdgYabPyirFp
</commit_message>
<xml_diff>
--- a/presentation_full(diagram change).pptx
+++ b/presentation_full(diagram change).pptx
@@ -4909,27 +4909,6 @@
                 <a:cs typeface="Noto Sans CJK KR" pitchFamily="34" charset="-120"/>
               </a:rPr>
               <a:t>각 슬롯은 자신의 타임슬롯에서 자신의 payload를 전송 (슬롯별 절대 타겟 틱을 기준으로 순회)</a:t>
-            </a:r>
-            <a:endParaRPr lang="en-US" sz="2000" dirty="0"/>
-          </a:p>
-          <a:p>
-            <a:pPr marL="342900" indent="-342900">
-              <a:spcAft>
-                <a:spcPts val="1200"/>
-              </a:spcAft>
-              <a:buSzPct val="100000"/>
-              <a:buChar char="•"/>
-            </a:pPr>
-            <a:r>
-              <a:rPr lang="en-US" sz="2000" dirty="0">
-                <a:solidFill>
-                  <a:srgbClr val="222222"/>
-                </a:solidFill>
-                <a:latin typeface="Noto Sans CJK KR" pitchFamily="34" charset="0"/>
-                <a:ea typeface="Noto Sans CJK KR" pitchFamily="34" charset="-122"/>
-                <a:cs typeface="Noto Sans CJK KR" pitchFamily="34" charset="-120"/>
-              </a:rPr>
-              <a:t>슬롯 0~5는 AXI 레지스터, 슬롯 6~7은 외부 PL 버스에서 payload를 가져옴</a:t>
             </a:r>
             <a:endParaRPr lang="en-US" sz="2000" dirty="0"/>
           </a:p>

</xml_diff>